<commit_message>
feat(pdf): keepHeadersAndFootersInPages keeps running headers and footers in their pages
A tagged PDF marks its running headers and footers as artifacts, and they are read into auxiliary,
where writers that lay out no pages (text, Markdown, HTML, EPUB, slides) leave them out. With
pdfParserConfig.keepHeadersAndFootersInPages each page keeps its own in its content, the header before
the page's text and the footer after it, placed before the page's pictures are, for a page-faithful
result such as a slide per page. ignoreHeadersAndFooters still drops them. Baselines carry the new key
and the automatic chart titles of the last commit.
</commit_message>
<xml_diff>
--- a/test/generator/baseline/gen.pptx.to.pptx.pptx
+++ b/test/generator/baseline/gen.pptx.to.pptx.pptx
@@ -14426,7 +14426,134 @@
                 <a:gridCol w="2493818"/>
                 <a:gridCol w="1108364"/>
               </a:tblGrid>
-              <a:tr h="829310">
+              <a:tr h="691092">
+                <a:tc gridSpan="4">
+                  <a:txBody>
+                    <a:bodyPr/>
+                    <a:lstStyle/>
+                    <a:p>
+                      <a:pPr>
+                        <a:buNone/>
+                      </a:pPr>
+                      <a:r>
+                        <a:rPr lang="en-US" sz="1200" b="1" dirty="0"/>
+                        <a:t>Chart Title</a:t>
+                      </a:r>
+                      <a:endParaRPr lang="en-US" sz="1200" dirty="0"/>
+                    </a:p>
+                  </a:txBody>
+                  <a:tcPr>
+                    <a:lnL w="9525">
+                      <a:solidFill>
+                        <a:srgbClr val="BFBFBF"/>
+                      </a:solidFill>
+                    </a:lnL>
+                    <a:lnR w="9525">
+                      <a:solidFill>
+                        <a:srgbClr val="BFBFBF"/>
+                      </a:solidFill>
+                    </a:lnR>
+                    <a:lnT w="9525">
+                      <a:solidFill>
+                        <a:srgbClr val="BFBFBF"/>
+                      </a:solidFill>
+                    </a:lnT>
+                    <a:lnB w="9525">
+                      <a:solidFill>
+                        <a:srgbClr val="BFBFBF"/>
+                      </a:solidFill>
+                    </a:lnB>
+                  </a:tcPr>
+                </a:tc>
+                <a:tc hMerge="1">
+                  <a:txBody>
+                    <a:bodyPr/>
+                    <a:lstStyle/>
+                    <a:p/>
+                  </a:txBody>
+                  <a:tcPr>
+                    <a:lnL w="9525">
+                      <a:solidFill>
+                        <a:srgbClr val="BFBFBF"/>
+                      </a:solidFill>
+                    </a:lnL>
+                    <a:lnR w="9525">
+                      <a:solidFill>
+                        <a:srgbClr val="BFBFBF"/>
+                      </a:solidFill>
+                    </a:lnR>
+                    <a:lnT w="9525">
+                      <a:solidFill>
+                        <a:srgbClr val="BFBFBF"/>
+                      </a:solidFill>
+                    </a:lnT>
+                    <a:lnB w="9525">
+                      <a:solidFill>
+                        <a:srgbClr val="BFBFBF"/>
+                      </a:solidFill>
+                    </a:lnB>
+                  </a:tcPr>
+                </a:tc>
+                <a:tc hMerge="1">
+                  <a:txBody>
+                    <a:bodyPr/>
+                    <a:lstStyle/>
+                    <a:p/>
+                  </a:txBody>
+                  <a:tcPr>
+                    <a:lnL w="9525">
+                      <a:solidFill>
+                        <a:srgbClr val="BFBFBF"/>
+                      </a:solidFill>
+                    </a:lnL>
+                    <a:lnR w="9525">
+                      <a:solidFill>
+                        <a:srgbClr val="BFBFBF"/>
+                      </a:solidFill>
+                    </a:lnR>
+                    <a:lnT w="9525">
+                      <a:solidFill>
+                        <a:srgbClr val="BFBFBF"/>
+                      </a:solidFill>
+                    </a:lnT>
+                    <a:lnB w="9525">
+                      <a:solidFill>
+                        <a:srgbClr val="BFBFBF"/>
+                      </a:solidFill>
+                    </a:lnB>
+                  </a:tcPr>
+                </a:tc>
+                <a:tc hMerge="1">
+                  <a:txBody>
+                    <a:bodyPr/>
+                    <a:lstStyle/>
+                    <a:p/>
+                  </a:txBody>
+                  <a:tcPr>
+                    <a:lnL w="9525">
+                      <a:solidFill>
+                        <a:srgbClr val="BFBFBF"/>
+                      </a:solidFill>
+                    </a:lnL>
+                    <a:lnR w="9525">
+                      <a:solidFill>
+                        <a:srgbClr val="BFBFBF"/>
+                      </a:solidFill>
+                    </a:lnR>
+                    <a:lnT w="9525">
+                      <a:solidFill>
+                        <a:srgbClr val="BFBFBF"/>
+                      </a:solidFill>
+                    </a:lnT>
+                    <a:lnB w="9525">
+                      <a:solidFill>
+                        <a:srgbClr val="BFBFBF"/>
+                      </a:solidFill>
+                    </a:lnB>
+                  </a:tcPr>
+                </a:tc>
+              </a:tr>
+              <a:tr h="691092">
                 <a:tc>
                   <a:txBody>
                     <a:bodyPr/>
@@ -14576,7 +14703,7 @@
                   </a:tcPr>
                 </a:tc>
               </a:tr>
-              <a:tr h="829310">
+              <a:tr h="691092">
                 <a:tc>
                   <a:txBody>
                     <a:bodyPr/>
@@ -14730,7 +14857,7 @@
                   </a:tcPr>
                 </a:tc>
               </a:tr>
-              <a:tr h="829310">
+              <a:tr h="691092">
                 <a:tc>
                   <a:txBody>
                     <a:bodyPr/>
@@ -14884,7 +15011,7 @@
                   </a:tcPr>
                 </a:tc>
               </a:tr>
-              <a:tr h="829310">
+              <a:tr h="691092">
                 <a:tc>
                   <a:txBody>
                     <a:bodyPr/>
@@ -15038,7 +15165,7 @@
                   </a:tcPr>
                 </a:tc>
               </a:tr>
-              <a:tr h="829310">
+              <a:tr h="691092">
                 <a:tc>
                   <a:txBody>
                     <a:bodyPr/>

</xml_diff>